<commit_message>
Edits to the poster
</commit_message>
<xml_diff>
--- a/semdial-2025/poster.pptx
+++ b/semdial-2025/poster.pptx
@@ -299,7 +299,7 @@
             </a:pPr>
             <a:fld id="{5CC2A059-B141-45A7-B910-B096D6D06820}" type="slidenum">
               <a:rPr/>
-              <a:t>‹Nr.›</a:t>
+              <a:t>‹#›</a:t>
             </a:fld>
             <a:endParaRPr/>
           </a:p>
@@ -515,7 +515,7 @@
             </a:pPr>
             <a:fld id="{5CC2A059-B141-45A7-B910-B096D6D06820}" type="slidenum">
               <a:rPr/>
-              <a:t>‹Nr.›</a:t>
+              <a:t>‹#›</a:t>
             </a:fld>
             <a:endParaRPr/>
           </a:p>
@@ -806,7 +806,7 @@
         <p:spPr bwMode="auto">
           <a:xfrm>
             <a:off x="1432391" y="18544887"/>
-            <a:ext cx="27397830" cy="22090411"/>
+            <a:ext cx="27397830" cy="22294694"/>
           </a:xfrm>
           <a:prstGeom prst="rect">
             <a:avLst/>
@@ -826,7 +826,7 @@
             <a:pPr>
               <a:defRPr/>
             </a:pPr>
-            <a:endParaRPr lang="en-US" noProof="0" dirty="0"/>
+            <a:endParaRPr lang="en-US" noProof="0"/>
           </a:p>
         </p:txBody>
       </p:sp>
@@ -945,8 +945,8 @@
         </p:nvSpPr>
         <p:spPr bwMode="auto">
           <a:xfrm>
-            <a:off x="1671316" y="9070314"/>
-            <a:ext cx="8291099" cy="8708615"/>
+            <a:off x="1671316" y="9685867"/>
+            <a:ext cx="8291099" cy="7477508"/>
           </a:xfrm>
           <a:prstGeom prst="rect">
             <a:avLst/>
@@ -975,7 +975,29 @@
                 <a:ea typeface="Liberation Sans"/>
                 <a:cs typeface="Liberation Sans"/>
               </a:rPr>
-              <a:t>A picture can say thousand words...</a:t>
+              <a:t>A picture </a:t>
+            </a:r>
+            <a:r>
+              <a:rPr lang="en-US" sz="4000" i="1" dirty="0">
+                <a:solidFill>
+                  <a:srgbClr val="000000"/>
+                </a:solidFill>
+                <a:latin typeface="Liberation Sans"/>
+                <a:ea typeface="Liberation Sans"/>
+                <a:cs typeface="Liberation Sans"/>
+              </a:rPr>
+              <a:t>is worth a</a:t>
+            </a:r>
+            <a:r>
+              <a:rPr lang="en-US" sz="4000" b="0" i="1" u="none" strike="noStrike" cap="none" spc="0" noProof="0" dirty="0">
+                <a:solidFill>
+                  <a:srgbClr val="000000"/>
+                </a:solidFill>
+                <a:latin typeface="Liberation Sans"/>
+                <a:ea typeface="Liberation Sans"/>
+                <a:cs typeface="Liberation Sans"/>
+              </a:rPr>
+              <a:t> thousand words...</a:t>
             </a:r>
           </a:p>
           <a:p>
@@ -1134,7 +1156,7 @@
                 <a:ea typeface="Liberation Sans"/>
                 <a:cs typeface="Liberation Sans"/>
               </a:rPr>
-              <a:t>Investigate the</a:t>
+              <a:t>Investigate the effects of </a:t>
             </a:r>
             <a:r>
               <a:rPr lang="en-US" sz="4000" b="1" i="0" u="none" strike="noStrike" cap="none" spc="0" noProof="0" dirty="0">
@@ -1145,7 +1167,51 @@
                 <a:ea typeface="Liberation Sans"/>
                 <a:cs typeface="Liberation Sans"/>
               </a:rPr>
-              <a:t> role of scene complexity</a:t>
+              <a:t>structured </a:t>
+            </a:r>
+            <a:r>
+              <a:rPr lang="en-US" sz="4000" b="1" dirty="0">
+                <a:solidFill>
+                  <a:srgbClr val="000000"/>
+                </a:solidFill>
+                <a:latin typeface="Liberation Sans"/>
+                <a:ea typeface="Liberation Sans"/>
+                <a:cs typeface="Liberation Sans"/>
+              </a:rPr>
+              <a:t>biases</a:t>
+            </a:r>
+            <a:r>
+              <a:rPr lang="en-US" sz="4000" b="1" i="0" u="none" strike="noStrike" cap="none" spc="0" noProof="0" dirty="0">
+                <a:solidFill>
+                  <a:srgbClr val="000000"/>
+                </a:solidFill>
+                <a:latin typeface="Liberation Sans"/>
+                <a:ea typeface="Liberation Sans"/>
+                <a:cs typeface="Liberation Sans"/>
+              </a:rPr>
+              <a:t> </a:t>
+            </a:r>
+            <a:r>
+              <a:rPr lang="en-US" sz="4000" i="0" u="none" strike="noStrike" cap="none" spc="0" noProof="0" dirty="0">
+                <a:solidFill>
+                  <a:srgbClr val="000000"/>
+                </a:solidFill>
+                <a:latin typeface="Liberation Sans"/>
+                <a:ea typeface="Liberation Sans"/>
+                <a:cs typeface="Liberation Sans"/>
+              </a:rPr>
+              <a:t>of</a:t>
+            </a:r>
+            <a:r>
+              <a:rPr lang="en-US" sz="4000" b="1" i="0" u="none" strike="noStrike" cap="none" spc="0" noProof="0" dirty="0">
+                <a:solidFill>
+                  <a:srgbClr val="000000"/>
+                </a:solidFill>
+                <a:latin typeface="Liberation Sans"/>
+                <a:ea typeface="Liberation Sans"/>
+                <a:cs typeface="Liberation Sans"/>
+              </a:rPr>
+              <a:t> scene complexity</a:t>
             </a:r>
             <a:r>
               <a:rPr lang="en-US" sz="4000" b="0" i="0" u="none" strike="noStrike" cap="none" spc="0" noProof="0" dirty="0">
@@ -1167,7 +1233,18 @@
                 <a:ea typeface="Liberation Sans"/>
                 <a:cs typeface="Liberation Sans"/>
               </a:rPr>
-              <a:t>discriminating features present</a:t>
+              <a:t>discriminating features </a:t>
+            </a:r>
+            <a:r>
+              <a:rPr lang="en-US" sz="4000" i="0" u="none" strike="noStrike" cap="none" spc="0" noProof="0" dirty="0">
+                <a:solidFill>
+                  <a:srgbClr val="000000"/>
+                </a:solidFill>
+                <a:latin typeface="Liberation Sans"/>
+                <a:ea typeface="Liberation Sans"/>
+                <a:cs typeface="Liberation Sans"/>
+              </a:rPr>
+              <a:t>present</a:t>
             </a:r>
             <a:r>
               <a:rPr lang="en-US" sz="4000" b="0" i="0" u="none" strike="noStrike" cap="none" spc="0" noProof="0" dirty="0">
@@ -1263,7 +1340,7 @@
               <a:pPr>
                 <a:defRPr/>
               </a:pPr>
-              <a:endParaRPr lang="en-US" noProof="0" dirty="0"/>
+              <a:endParaRPr lang="en-US" noProof="0"/>
             </a:p>
           </p:txBody>
         </p:sp>
@@ -1299,12 +1376,12 @@
                 <a:defRPr/>
               </a:pPr>
               <a:r>
-                <a:rPr lang="en-US" sz="5400" b="1" strike="noStrike" cap="small" noProof="0" dirty="0">
+                <a:rPr lang="en-US" sz="5400" b="1" strike="noStrike" cap="small" noProof="0">
                   <a:latin typeface="Liberation Serif"/>
                 </a:rPr>
                 <a:t>Setup</a:t>
               </a:r>
-              <a:endParaRPr lang="en-US" sz="5400" noProof="0" dirty="0"/>
+              <a:endParaRPr lang="en-US" sz="5400" noProof="0"/>
             </a:p>
           </p:txBody>
         </p:sp>
@@ -1352,7 +1429,7 @@
               <a:pPr>
                 <a:defRPr/>
               </a:pPr>
-              <a:endParaRPr lang="en-US" noProof="0" dirty="0"/>
+              <a:endParaRPr lang="en-US" noProof="0"/>
             </a:p>
           </p:txBody>
         </p:sp>
@@ -1441,7 +1518,7 @@
               <a:pPr>
                 <a:defRPr/>
               </a:pPr>
-              <a:endParaRPr lang="en-US" noProof="0" dirty="0"/>
+              <a:endParaRPr lang="en-US" noProof="0"/>
             </a:p>
           </p:txBody>
         </p:sp>
@@ -1454,7 +1531,7 @@
           <p:spPr bwMode="auto">
             <a:xfrm>
               <a:off x="172692" y="0"/>
-              <a:ext cx="4008171" cy="913311"/>
+              <a:ext cx="3019494" cy="921866"/>
             </a:xfrm>
             <a:prstGeom prst="rect">
               <a:avLst/>
@@ -1468,7 +1545,7 @@
             <a:effectLst/>
           </p:spPr>
           <p:txBody>
-            <a:bodyPr lIns="89992" tIns="44995" rIns="89992" bIns="44995">
+            <a:bodyPr wrap="square" lIns="89992" tIns="44995" rIns="89992" bIns="44995">
               <a:spAutoFit/>
             </a:bodyPr>
             <a:lstStyle/>
@@ -1477,12 +1554,12 @@
                 <a:defRPr/>
               </a:pPr>
               <a:r>
-                <a:rPr lang="en-US" sz="5400" b="1" strike="noStrike" cap="small" noProof="0" dirty="0">
+                <a:rPr lang="en-US" sz="5400" b="1" cap="small" noProof="0">
                   <a:latin typeface="Liberation Serif"/>
                 </a:rPr>
-                <a:t>Conclusion</a:t>
+                <a:t>Findings</a:t>
               </a:r>
-              <a:endParaRPr lang="en-US" sz="5400" noProof="0" dirty="0"/>
+              <a:endParaRPr lang="en-US" sz="5400" noProof="0"/>
             </a:p>
           </p:txBody>
         </p:sp>
@@ -1517,8 +1594,8 @@
         </p:nvSpPr>
         <p:spPr bwMode="auto">
           <a:xfrm>
-            <a:off x="20197884" y="9209228"/>
-            <a:ext cx="8286419" cy="8049838"/>
+            <a:off x="20197884" y="8879842"/>
+            <a:ext cx="8286419" cy="8708613"/>
           </a:xfrm>
           <a:prstGeom prst="rect">
             <a:avLst/>
@@ -1570,6 +1647,54 @@
               <a:defRPr/>
             </a:pPr>
             <a:r>
+              <a:rPr lang="en-US" sz="4000" dirty="0">
+                <a:solidFill>
+                  <a:srgbClr val="000000"/>
+                </a:solidFill>
+                <a:latin typeface="Liberation Sans"/>
+                <a:ea typeface="Liberation Sans"/>
+                <a:cs typeface="Liberation Sans"/>
+              </a:rPr>
+              <a:t>Emergent vocabularies </a:t>
+            </a:r>
+            <a:r>
+              <a:rPr lang="en-US" sz="4000" b="1" dirty="0">
+                <a:solidFill>
+                  <a:srgbClr val="000000"/>
+                </a:solidFill>
+                <a:latin typeface="Liberation Sans"/>
+                <a:ea typeface="Liberation Sans"/>
+                <a:cs typeface="Liberation Sans"/>
+              </a:rPr>
+              <a:t>align with the structured contextual biases</a:t>
+            </a:r>
+            <a:r>
+              <a:rPr lang="en-US" sz="4000" dirty="0">
+                <a:solidFill>
+                  <a:srgbClr val="000000"/>
+                </a:solidFill>
+                <a:latin typeface="Liberation Sans"/>
+                <a:ea typeface="Liberation Sans"/>
+                <a:cs typeface="Liberation Sans"/>
+              </a:rPr>
+              <a:t> introduced</a:t>
+            </a:r>
+            <a:endParaRPr lang="en-US" sz="4000" b="0" i="0" u="none" strike="noStrike" cap="none" spc="0" noProof="0" dirty="0">
+              <a:solidFill>
+                <a:srgbClr val="000000"/>
+              </a:solidFill>
+              <a:latin typeface="Liberation Sans"/>
+              <a:ea typeface="Liberation Sans"/>
+              <a:cs typeface="Liberation Sans"/>
+            </a:endParaRPr>
+          </a:p>
+          <a:p>
+            <a:pPr marL="526195" indent="-526195">
+              <a:buFont typeface="Arial"/>
+              <a:buChar char="•"/>
+              <a:defRPr/>
+            </a:pPr>
+            <a:r>
               <a:rPr lang="en-US" sz="4000" b="0" i="0" u="none" strike="noStrike" cap="none" spc="0" noProof="0" dirty="0">
                 <a:solidFill>
                   <a:srgbClr val="000000"/>
@@ -1600,7 +1725,18 @@
                 <a:ea typeface="Liberation Sans"/>
                 <a:cs typeface="Liberation Sans"/>
               </a:rPr>
-              <a:t>) dramatically</a:t>
+              <a:t>) </a:t>
+            </a:r>
+            <a:r>
+              <a:rPr lang="en-US" sz="4000" dirty="0">
+                <a:solidFill>
+                  <a:srgbClr val="000000"/>
+                </a:solidFill>
+                <a:latin typeface="Liberation Sans"/>
+                <a:ea typeface="Liberation Sans"/>
+                <a:cs typeface="Liberation Sans"/>
+              </a:rPr>
+              <a:t>strongly</a:t>
             </a:r>
             <a:r>
               <a:rPr lang="en-US" sz="4000" b="0" i="0" u="none" strike="noStrike" cap="none" spc="0" noProof="0" dirty="0">
@@ -1726,6 +1862,17 @@
               <a:defRPr/>
             </a:pPr>
             <a:r>
+              <a:rPr lang="en-US" sz="4000" b="1" i="0" u="none" strike="noStrike" cap="none" spc="0" noProof="0" dirty="0">
+                <a:solidFill>
+                  <a:srgbClr val="000000"/>
+                </a:solidFill>
+                <a:latin typeface="Liberation Sans"/>
+                <a:ea typeface="Liberation Sans"/>
+                <a:cs typeface="Liberation Sans"/>
+              </a:rPr>
+              <a:t>Future:</a:t>
+            </a:r>
+            <a:r>
               <a:rPr lang="en-US" sz="4000" b="0" i="0" u="none" strike="noStrike" cap="none" spc="0" noProof="0" dirty="0">
                 <a:solidFill>
                   <a:srgbClr val="000000"/>
@@ -1734,28 +1881,7 @@
                 <a:ea typeface="Liberation Sans"/>
                 <a:cs typeface="Liberation Sans"/>
               </a:rPr>
-              <a:t>Future: Analyze linguistic properties of</a:t>
-            </a:r>
-            <a:r>
-              <a:rPr lang="en-US" sz="4000" b="0" i="0" u="none" strike="noStrike" cap="none" spc="0" noProof="0" dirty="0">
-                <a:solidFill>
-                  <a:srgbClr val="000000"/>
-                </a:solidFill>
-                <a:latin typeface="Liberation Sans"/>
-                <a:cs typeface="Liberation Sans"/>
-              </a:rPr>
-              <a:t> </a:t>
-            </a:r>
-            <a:r>
-              <a:rPr lang="en-US" sz="4000" b="0" i="0" u="none" strike="noStrike" cap="none" spc="0" noProof="0" dirty="0">
-                <a:solidFill>
-                  <a:srgbClr val="000000"/>
-                </a:solidFill>
-                <a:latin typeface="Liberation Sans"/>
-                <a:ea typeface="Liberation Sans"/>
-                <a:cs typeface="Liberation Sans"/>
-              </a:rPr>
-              <a:t>emergent languages</a:t>
+              <a:t> Compare emergent vocabularies and languages with (different) natural languages</a:t>
             </a:r>
             <a:endParaRPr lang="en-US" sz="4000" b="0" i="0" u="none" strike="noStrike" cap="none" spc="0" noProof="0" dirty="0">
               <a:solidFill>
@@ -1793,7 +1919,9 @@
               <a:defRPr/>
             </a:pPr>
             <a:r>
-              <a:rPr lang="en-US" sz="2800" noProof="0" dirty="0"/>
+              <a:rPr lang="en-US" sz="2800" noProof="0" dirty="0">
+                <a:latin typeface="Liberation Sans Narrow" panose="020B0606020202030204" pitchFamily="34" charset="0"/>
+              </a:rPr>
               <a:t>16th International Conference on Computational Semantics (IWCS 2025)</a:t>
             </a:r>
           </a:p>
@@ -1819,7 +1947,7 @@
         </p:blipFill>
         <p:spPr bwMode="auto">
           <a:xfrm>
-            <a:off x="25184099" y="40919400"/>
+            <a:off x="25401221" y="41246206"/>
             <a:ext cx="3429000" cy="1000125"/>
           </a:xfrm>
           <a:prstGeom prst="rect">
@@ -1919,7 +2047,7 @@
         </p:blipFill>
         <p:spPr bwMode="auto">
           <a:xfrm>
-            <a:off x="20708641" y="34144462"/>
+            <a:off x="20711764" y="34385736"/>
             <a:ext cx="8037683" cy="6262236"/>
           </a:xfrm>
           <a:prstGeom prst="rect">
@@ -1941,7 +2069,7 @@
         </p:blipFill>
         <p:spPr bwMode="auto">
           <a:xfrm>
-            <a:off x="4426165" y="34142504"/>
+            <a:off x="4429288" y="34383778"/>
             <a:ext cx="8040197" cy="6264194"/>
           </a:xfrm>
           <a:prstGeom prst="rect">
@@ -1963,7 +2091,7 @@
         </p:blipFill>
         <p:spPr bwMode="auto">
           <a:xfrm>
-            <a:off x="12642790" y="34143718"/>
+            <a:off x="12645913" y="34384992"/>
             <a:ext cx="8038638" cy="6262980"/>
           </a:xfrm>
           <a:prstGeom prst="rect">
@@ -1980,7 +2108,7 @@
           <p:nvPr>
             <p:extLst>
               <p:ext uri="{D42A27DB-BD31-4B8C-83A1-F6EECF244321}">
-                <p14:modId xmlns:p14="http://schemas.microsoft.com/office/powerpoint/2010/main" val="1626041262"/>
+                <p14:modId xmlns:p14="http://schemas.microsoft.com/office/powerpoint/2010/main" val="1445686652"/>
               </p:ext>
             </p:extLst>
           </p:nvPr>
@@ -2035,29 +2163,41 @@
                         <a:defRPr/>
                       </a:pPr>
                       <a:r>
-                        <a:rPr lang="de-DE" sz="3600" b="1" dirty="0" err="1"/>
+                        <a:rPr lang="de-DE" sz="3600" b="1" dirty="0" err="1">
+                          <a:latin typeface="Liberation Sans Narrow" panose="020B0606020202030204" pitchFamily="34" charset="0"/>
+                        </a:rPr>
                         <a:t>Strict</a:t>
                       </a:r>
                       <a:r>
-                        <a:rPr lang="de-DE" sz="3600" b="1" dirty="0"/>
+                        <a:rPr lang="de-DE" sz="3600" b="1" dirty="0">
+                          <a:latin typeface="Liberation Sans Narrow" panose="020B0606020202030204" pitchFamily="34" charset="0"/>
+                        </a:rPr>
                         <a:t> </a:t>
                       </a:r>
                       <a:r>
-                        <a:rPr lang="de-DE" sz="3600" b="1" dirty="0" err="1"/>
+                        <a:rPr lang="de-DE" sz="3600" b="1" dirty="0" err="1">
+                          <a:latin typeface="Liberation Sans Narrow" panose="020B0606020202030204" pitchFamily="34" charset="0"/>
+                        </a:rPr>
                         <a:t>string</a:t>
                       </a:r>
                       <a:r>
-                        <a:rPr lang="de-DE" sz="3600" b="1" dirty="0"/>
+                        <a:rPr lang="de-DE" sz="3600" b="1" dirty="0">
+                          <a:latin typeface="Liberation Sans Narrow" panose="020B0606020202030204" pitchFamily="34" charset="0"/>
+                        </a:rPr>
                         <a:t> </a:t>
                       </a:r>
                       <a:r>
-                        <a:rPr lang="de-DE" sz="3600" b="1" dirty="0" err="1"/>
+                        <a:rPr lang="de-DE" sz="3600" b="1" dirty="0" err="1">
+                          <a:latin typeface="Liberation Sans Narrow" panose="020B0606020202030204" pitchFamily="34" charset="0"/>
+                        </a:rPr>
                         <a:t>accuracy</a:t>
                       </a:r>
-                      <a:endParaRPr sz="3600" b="1" dirty="0"/>
+                      <a:endParaRPr sz="3600" b="1" dirty="0">
+                        <a:latin typeface="Liberation Sans Narrow" panose="020B0606020202030204" pitchFamily="34" charset="0"/>
+                      </a:endParaRPr>
                     </a:p>
                   </a:txBody>
-                  <a:tcPr anchor="ctr">
+                  <a:tcPr marL="90000" anchor="ctr">
                     <a:lnL w="6349" algn="ctr">
                       <a:noFill/>
                     </a:lnL>
@@ -2095,13 +2235,17 @@
                         <a:defRPr/>
                       </a:pPr>
                       <a:r>
-                        <a:rPr lang="de-DE" sz="3600" dirty="0"/>
+                        <a:rPr lang="de-DE" sz="3600" dirty="0">
+                          <a:latin typeface="Liberation Sans Narrow" panose="020B0606020202030204" pitchFamily="34" charset="0"/>
+                        </a:rPr>
                         <a:t>99%</a:t>
                       </a:r>
-                      <a:endParaRPr sz="3600" dirty="0"/>
+                      <a:endParaRPr sz="3600" dirty="0">
+                        <a:latin typeface="Liberation Sans Narrow" panose="020B0606020202030204" pitchFamily="34" charset="0"/>
+                      </a:endParaRPr>
                     </a:p>
                   </a:txBody>
-                  <a:tcPr anchor="ctr">
+                  <a:tcPr marL="90000" anchor="ctr">
                     <a:lnL w="6349" algn="ctr">
                       <a:noFill/>
                     </a:lnL>
@@ -2145,13 +2289,17 @@
                         <a:defRPr/>
                       </a:pPr>
                       <a:r>
-                        <a:rPr lang="de-DE" sz="3600" dirty="0"/>
+                        <a:rPr lang="de-DE" sz="3600" dirty="0">
+                          <a:latin typeface="Liberation Sans Narrow" panose="020B0606020202030204" pitchFamily="34" charset="0"/>
+                        </a:rPr>
                         <a:t>69%</a:t>
                       </a:r>
-                      <a:endParaRPr sz="3600" dirty="0"/>
+                      <a:endParaRPr sz="3600" dirty="0">
+                        <a:latin typeface="Liberation Sans Narrow" panose="020B0606020202030204" pitchFamily="34" charset="0"/>
+                      </a:endParaRPr>
                     </a:p>
                   </a:txBody>
-                  <a:tcPr anchor="ctr">
+                  <a:tcPr marL="90000" anchor="ctr">
                     <a:lnL w="12700" cap="flat" cmpd="sng" algn="ctr">
                       <a:solidFill>
                         <a:schemeClr val="tx1"/>
@@ -2201,13 +2349,17 @@
                         <a:defRPr/>
                       </a:pPr>
                       <a:r>
-                        <a:rPr lang="de-DE" sz="3600" dirty="0"/>
+                        <a:rPr lang="de-DE" sz="3600" dirty="0">
+                          <a:latin typeface="Liberation Sans Narrow" panose="020B0606020202030204" pitchFamily="34" charset="0"/>
+                        </a:rPr>
                         <a:t>93%</a:t>
                       </a:r>
-                      <a:endParaRPr sz="3600" dirty="0"/>
+                      <a:endParaRPr sz="3600" dirty="0">
+                        <a:latin typeface="Liberation Sans Narrow" panose="020B0606020202030204" pitchFamily="34" charset="0"/>
+                      </a:endParaRPr>
                     </a:p>
                   </a:txBody>
-                  <a:tcPr anchor="ctr">
+                  <a:tcPr marL="90000" anchor="ctr">
                     <a:lnL w="12700" cap="flat" cmpd="sng" algn="ctr">
                       <a:solidFill>
                         <a:schemeClr val="tx1"/>
@@ -2258,13 +2410,17 @@
                         <a:defRPr/>
                       </a:pPr>
                       <a:r>
-                        <a:rPr lang="de-DE" sz="3600" b="1"/>
+                        <a:rPr lang="de-DE" sz="3600" b="1" dirty="0">
+                          <a:latin typeface="Liberation Sans Narrow" panose="020B0606020202030204" pitchFamily="34" charset="0"/>
+                        </a:rPr>
                         <a:t>F1 score</a:t>
                       </a:r>
-                      <a:endParaRPr sz="3600" b="1"/>
+                      <a:endParaRPr sz="3600" b="1" dirty="0">
+                        <a:latin typeface="Liberation Sans Narrow" panose="020B0606020202030204" pitchFamily="34" charset="0"/>
+                      </a:endParaRPr>
                     </a:p>
                   </a:txBody>
-                  <a:tcPr anchor="ctr">
+                  <a:tcPr marL="90000" anchor="ctr">
                     <a:lnL w="6349" algn="ctr">
                       <a:noFill/>
                     </a:lnL>
@@ -2308,13 +2464,17 @@
                         <a:defRPr/>
                       </a:pPr>
                       <a:r>
-                        <a:rPr lang="de-DE" sz="3600" dirty="0"/>
+                        <a:rPr lang="de-DE" sz="3600" dirty="0">
+                          <a:latin typeface="Liberation Sans Narrow" panose="020B0606020202030204" pitchFamily="34" charset="0"/>
+                        </a:rPr>
                         <a:t>98,57%</a:t>
                       </a:r>
-                      <a:endParaRPr sz="3600" dirty="0"/>
+                      <a:endParaRPr sz="3600" dirty="0">
+                        <a:latin typeface="Liberation Sans Narrow" panose="020B0606020202030204" pitchFamily="34" charset="0"/>
+                      </a:endParaRPr>
                     </a:p>
                   </a:txBody>
-                  <a:tcPr anchor="ctr">
+                  <a:tcPr marL="90000" anchor="ctr">
                     <a:lnL w="6349" algn="ctr">
                       <a:noFill/>
                     </a:lnL>
@@ -2364,13 +2524,17 @@
                         <a:defRPr/>
                       </a:pPr>
                       <a:r>
-                        <a:rPr lang="de-DE" sz="3600" dirty="0"/>
+                        <a:rPr lang="de-DE" sz="3600" dirty="0">
+                          <a:latin typeface="Liberation Sans Narrow" panose="020B0606020202030204" pitchFamily="34" charset="0"/>
+                        </a:rPr>
                         <a:t>89,53%</a:t>
                       </a:r>
-                      <a:endParaRPr sz="3600" dirty="0"/>
+                      <a:endParaRPr sz="3600" dirty="0">
+                        <a:latin typeface="Liberation Sans Narrow" panose="020B0606020202030204" pitchFamily="34" charset="0"/>
+                      </a:endParaRPr>
                     </a:p>
                   </a:txBody>
-                  <a:tcPr anchor="ctr">
+                  <a:tcPr marL="90000" anchor="ctr">
                     <a:lnL w="12700" cap="flat" cmpd="sng" algn="ctr">
                       <a:solidFill>
                         <a:schemeClr val="tx1"/>
@@ -2426,13 +2590,17 @@
                         <a:defRPr/>
                       </a:pPr>
                       <a:r>
-                        <a:rPr lang="de-DE" sz="3600" dirty="0"/>
+                        <a:rPr lang="de-DE" sz="3600" dirty="0">
+                          <a:latin typeface="Liberation Sans Narrow" panose="020B0606020202030204" pitchFamily="34" charset="0"/>
+                        </a:rPr>
                         <a:t>95,17%</a:t>
                       </a:r>
-                      <a:endParaRPr sz="3600" dirty="0"/>
+                      <a:endParaRPr sz="3600" dirty="0">
+                        <a:latin typeface="Liberation Sans Narrow" panose="020B0606020202030204" pitchFamily="34" charset="0"/>
+                      </a:endParaRPr>
                     </a:p>
                   </a:txBody>
-                  <a:tcPr anchor="ctr">
+                  <a:tcPr marL="90000" anchor="ctr">
                     <a:lnL w="12700" cap="flat" cmpd="sng" algn="ctr">
                       <a:solidFill>
                         <a:schemeClr val="tx1"/>
@@ -2489,13 +2657,40 @@
                         <a:defRPr/>
                       </a:pPr>
                       <a:r>
-                        <a:rPr lang="de-DE" sz="3600" b="1"/>
-                        <a:t>Shape Precision</a:t>
+                        <a:rPr lang="de-DE" sz="3600" b="1" dirty="0">
+                          <a:latin typeface="Liberation Sans Narrow" panose="020B0606020202030204" pitchFamily="34" charset="0"/>
+                        </a:rPr>
+                        <a:t>Shape </a:t>
                       </a:r>
-                      <a:endParaRPr sz="3600" b="1"/>
+                    </a:p>
+                    <a:p>
+                      <a:pPr algn="r">
+                        <a:defRPr/>
+                      </a:pPr>
+                      <a:r>
+                        <a:rPr lang="de-DE" sz="3600" b="1" dirty="0" err="1">
+                          <a:latin typeface="Liberation Sans Narrow" panose="020B0606020202030204" pitchFamily="34" charset="0"/>
+                        </a:rPr>
+                        <a:t>Prec</a:t>
+                      </a:r>
+                      <a:r>
+                        <a:rPr lang="de-DE" sz="3600" b="1" dirty="0">
+                          <a:latin typeface="Liberation Sans Narrow" panose="020B0606020202030204" pitchFamily="34" charset="0"/>
+                        </a:rPr>
+                        <a:t> / </a:t>
+                      </a:r>
+                      <a:r>
+                        <a:rPr lang="de-DE" sz="3600" b="1" dirty="0" err="1">
+                          <a:latin typeface="Liberation Sans Narrow" panose="020B0606020202030204" pitchFamily="34" charset="0"/>
+                        </a:rPr>
+                        <a:t>Rec</a:t>
+                      </a:r>
+                      <a:endParaRPr sz="3600" b="1" dirty="0">
+                        <a:latin typeface="Liberation Sans Narrow" panose="020B0606020202030204" pitchFamily="34" charset="0"/>
+                      </a:endParaRPr>
                     </a:p>
                   </a:txBody>
-                  <a:tcPr anchor="ctr">
+                  <a:tcPr marL="90000" anchor="ctr">
                     <a:lnL w="6349" algn="ctr">
                       <a:noFill/>
                     </a:lnL>
@@ -2539,13 +2734,17 @@
                         <a:defRPr/>
                       </a:pPr>
                       <a:r>
-                        <a:rPr lang="de-DE" sz="3600"/>
-                        <a:t>99,75%</a:t>
+                        <a:rPr lang="de-DE" sz="3600" dirty="0">
+                          <a:latin typeface="Liberation Sans Narrow" panose="020B0606020202030204" pitchFamily="34" charset="0"/>
+                        </a:rPr>
+                        <a:t>99,75% / 99,74% </a:t>
                       </a:r>
-                      <a:endParaRPr sz="3600"/>
+                      <a:endParaRPr sz="3600" dirty="0">
+                        <a:latin typeface="Liberation Sans Narrow" panose="020B0606020202030204" pitchFamily="34" charset="0"/>
+                      </a:endParaRPr>
                     </a:p>
                   </a:txBody>
-                  <a:tcPr anchor="ctr">
+                  <a:tcPr marL="90000" anchor="ctr">
                     <a:lnL w="6349" algn="ctr">
                       <a:noFill/>
                     </a:lnL>
@@ -2595,13 +2794,17 @@
                         <a:defRPr/>
                       </a:pPr>
                       <a:r>
-                        <a:rPr lang="de-DE" sz="3600" dirty="0"/>
-                        <a:t>98,30%</a:t>
+                        <a:rPr lang="de-DE" sz="3600" dirty="0">
+                          <a:latin typeface="Liberation Sans Narrow" panose="020B0606020202030204" pitchFamily="34" charset="0"/>
+                        </a:rPr>
+                        <a:t>98,30% / 98,3%</a:t>
                       </a:r>
-                      <a:endParaRPr sz="3600" dirty="0"/>
+                      <a:endParaRPr sz="3600" dirty="0">
+                        <a:latin typeface="Liberation Sans Narrow" panose="020B0606020202030204" pitchFamily="34" charset="0"/>
+                      </a:endParaRPr>
                     </a:p>
                   </a:txBody>
-                  <a:tcPr anchor="ctr">
+                  <a:tcPr marL="90000" anchor="ctr">
                     <a:lnL w="12700" cap="flat" cmpd="sng" algn="ctr">
                       <a:solidFill>
                         <a:schemeClr val="tx1"/>
@@ -2657,13 +2860,17 @@
                         <a:defRPr/>
                       </a:pPr>
                       <a:r>
-                        <a:rPr lang="de-DE" sz="3600"/>
-                        <a:t>100%</a:t>
+                        <a:rPr lang="de-DE" sz="3600" dirty="0">
+                          <a:latin typeface="Liberation Sans Narrow" panose="020B0606020202030204" pitchFamily="34" charset="0"/>
+                        </a:rPr>
+                        <a:t>100% / 100%</a:t>
                       </a:r>
-                      <a:endParaRPr sz="3600"/>
+                      <a:endParaRPr sz="3600" dirty="0">
+                        <a:latin typeface="Liberation Sans Narrow" panose="020B0606020202030204" pitchFamily="34" charset="0"/>
+                      </a:endParaRPr>
                     </a:p>
                   </a:txBody>
-                  <a:tcPr anchor="ctr">
+                  <a:tcPr marL="90000" anchor="ctr">
                     <a:lnL w="12700" cap="flat" cmpd="sng" algn="ctr">
                       <a:solidFill>
                         <a:schemeClr val="tx1"/>
@@ -2720,13 +2927,40 @@
                         <a:defRPr/>
                       </a:pPr>
                       <a:r>
-                        <a:rPr lang="de-DE" sz="3600" b="1"/>
-                        <a:t>Color Precision</a:t>
+                        <a:rPr lang="de-DE" sz="3600" b="1" dirty="0">
+                          <a:latin typeface="Liberation Sans Narrow" panose="020B0606020202030204" pitchFamily="34" charset="0"/>
+                        </a:rPr>
+                        <a:t>Color</a:t>
                       </a:r>
-                      <a:endParaRPr sz="3600" b="1"/>
+                    </a:p>
+                    <a:p>
+                      <a:pPr algn="r">
+                        <a:defRPr/>
+                      </a:pPr>
+                      <a:r>
+                        <a:rPr lang="de-DE" sz="3600" b="1" dirty="0" err="1">
+                          <a:latin typeface="Liberation Sans Narrow" panose="020B0606020202030204" pitchFamily="34" charset="0"/>
+                        </a:rPr>
+                        <a:t>Prec</a:t>
+                      </a:r>
+                      <a:r>
+                        <a:rPr lang="de-DE" sz="3600" b="1" dirty="0">
+                          <a:latin typeface="Liberation Sans Narrow" panose="020B0606020202030204" pitchFamily="34" charset="0"/>
+                        </a:rPr>
+                        <a:t> / </a:t>
+                      </a:r>
+                      <a:r>
+                        <a:rPr lang="de-DE" sz="3600" b="1" dirty="0" err="1">
+                          <a:latin typeface="Liberation Sans Narrow" panose="020B0606020202030204" pitchFamily="34" charset="0"/>
+                        </a:rPr>
+                        <a:t>Rec</a:t>
+                      </a:r>
+                      <a:endParaRPr sz="3600" b="1" dirty="0">
+                        <a:latin typeface="Liberation Sans Narrow" panose="020B0606020202030204" pitchFamily="34" charset="0"/>
+                      </a:endParaRPr>
                     </a:p>
                   </a:txBody>
-                  <a:tcPr anchor="ctr">
+                  <a:tcPr marL="90000" anchor="ctr">
                     <a:lnL w="6349" algn="ctr">
                       <a:noFill/>
                     </a:lnL>
@@ -2770,13 +3004,17 @@
                         <a:defRPr/>
                       </a:pPr>
                       <a:r>
-                        <a:rPr lang="de-DE" sz="3600"/>
-                        <a:t>98,09%</a:t>
+                        <a:rPr lang="de-DE" sz="3600" dirty="0">
+                          <a:latin typeface="Liberation Sans Narrow" panose="020B0606020202030204" pitchFamily="34" charset="0"/>
+                        </a:rPr>
+                        <a:t>98,09% / 98,53%</a:t>
                       </a:r>
-                      <a:endParaRPr sz="3600"/>
+                      <a:endParaRPr sz="3600" dirty="0">
+                        <a:latin typeface="Liberation Sans Narrow" panose="020B0606020202030204" pitchFamily="34" charset="0"/>
+                      </a:endParaRPr>
                     </a:p>
                   </a:txBody>
-                  <a:tcPr anchor="ctr">
+                  <a:tcPr marL="90000" anchor="ctr">
                     <a:lnL w="6349" algn="ctr">
                       <a:noFill/>
                     </a:lnL>
@@ -2826,13 +3064,17 @@
                         <a:defRPr/>
                       </a:pPr>
                       <a:r>
-                        <a:rPr lang="de-DE" sz="3600" dirty="0"/>
-                        <a:t>92,44%</a:t>
+                        <a:rPr lang="de-DE" sz="3600" dirty="0">
+                          <a:latin typeface="Liberation Sans Narrow" panose="020B0606020202030204" pitchFamily="34" charset="0"/>
+                        </a:rPr>
+                        <a:t>92,44% / 92,95%</a:t>
                       </a:r>
-                      <a:endParaRPr sz="3600" dirty="0"/>
+                      <a:endParaRPr sz="3600" dirty="0">
+                        <a:latin typeface="Liberation Sans Narrow" panose="020B0606020202030204" pitchFamily="34" charset="0"/>
+                      </a:endParaRPr>
                     </a:p>
                   </a:txBody>
-                  <a:tcPr anchor="ctr">
+                  <a:tcPr marL="90000" anchor="ctr">
                     <a:lnL w="12700" cap="flat" cmpd="sng" algn="ctr">
                       <a:solidFill>
                         <a:schemeClr val="tx1"/>
@@ -2888,13 +3130,17 @@
                         <a:defRPr/>
                       </a:pPr>
                       <a:r>
-                        <a:rPr lang="de-DE" sz="3600" dirty="0"/>
-                        <a:t>92,76%</a:t>
+                        <a:rPr lang="de-DE" sz="3600" dirty="0">
+                          <a:latin typeface="Liberation Sans Narrow" panose="020B0606020202030204" pitchFamily="34" charset="0"/>
+                        </a:rPr>
+                        <a:t>92,76% / 92,76%</a:t>
                       </a:r>
-                      <a:endParaRPr sz="3600" dirty="0"/>
+                      <a:endParaRPr sz="3600" dirty="0">
+                        <a:latin typeface="Liberation Sans Narrow" panose="020B0606020202030204" pitchFamily="34" charset="0"/>
+                      </a:endParaRPr>
                     </a:p>
                   </a:txBody>
-                  <a:tcPr anchor="ctr">
+                  <a:tcPr marL="90000" anchor="ctr">
                     <a:lnL w="12700" cap="flat" cmpd="sng" algn="ctr">
                       <a:solidFill>
                         <a:schemeClr val="tx1"/>
@@ -2951,13 +3197,40 @@
                         <a:defRPr/>
                       </a:pPr>
                       <a:r>
-                        <a:rPr lang="de-DE" sz="3600" b="1"/>
-                        <a:t>Size Precision</a:t>
+                        <a:rPr lang="de-DE" sz="3600" b="1" dirty="0">
+                          <a:latin typeface="Liberation Sans Narrow" panose="020B0606020202030204" pitchFamily="34" charset="0"/>
+                        </a:rPr>
+                        <a:t>Size </a:t>
                       </a:r>
-                      <a:endParaRPr sz="3600" b="1"/>
+                    </a:p>
+                    <a:p>
+                      <a:pPr algn="r">
+                        <a:defRPr/>
+                      </a:pPr>
+                      <a:r>
+                        <a:rPr lang="de-DE" sz="3600" b="1" dirty="0" err="1">
+                          <a:latin typeface="Liberation Sans Narrow" panose="020B0606020202030204" pitchFamily="34" charset="0"/>
+                        </a:rPr>
+                        <a:t>Prec</a:t>
+                      </a:r>
+                      <a:r>
+                        <a:rPr lang="de-DE" sz="3600" b="1" dirty="0">
+                          <a:latin typeface="Liberation Sans Narrow" panose="020B0606020202030204" pitchFamily="34" charset="0"/>
+                        </a:rPr>
+                        <a:t> / </a:t>
+                      </a:r>
+                      <a:r>
+                        <a:rPr lang="de-DE" sz="3600" b="1" dirty="0" err="1">
+                          <a:latin typeface="Liberation Sans Narrow" panose="020B0606020202030204" pitchFamily="34" charset="0"/>
+                        </a:rPr>
+                        <a:t>Rec</a:t>
+                      </a:r>
+                      <a:endParaRPr sz="3600" b="1" dirty="0">
+                        <a:latin typeface="Liberation Sans Narrow" panose="020B0606020202030204" pitchFamily="34" charset="0"/>
+                      </a:endParaRPr>
                     </a:p>
                   </a:txBody>
-                  <a:tcPr anchor="ctr">
+                  <a:tcPr marL="90000" anchor="ctr">
                     <a:lnL w="6349" algn="ctr">
                       <a:noFill/>
                     </a:lnL>
@@ -2995,13 +3268,17 @@
                         <a:defRPr/>
                       </a:pPr>
                       <a:r>
-                        <a:rPr lang="de-DE" sz="3600"/>
-                        <a:t>98,73%</a:t>
+                        <a:rPr lang="de-DE" sz="3600" dirty="0">
+                          <a:latin typeface="Liberation Sans Narrow" panose="020B0606020202030204" pitchFamily="34" charset="0"/>
+                        </a:rPr>
+                        <a:t>98,73% / 95,9%</a:t>
                       </a:r>
-                      <a:endParaRPr sz="3600"/>
+                      <a:endParaRPr sz="3600" dirty="0">
+                        <a:latin typeface="Liberation Sans Narrow" panose="020B0606020202030204" pitchFamily="34" charset="0"/>
+                      </a:endParaRPr>
                     </a:p>
                   </a:txBody>
-                  <a:tcPr anchor="ctr">
+                  <a:tcPr marL="90000" anchor="ctr">
                     <a:lnL w="6349" algn="ctr">
                       <a:noFill/>
                     </a:lnL>
@@ -3045,13 +3322,17 @@
                         <a:defRPr/>
                       </a:pPr>
                       <a:r>
-                        <a:rPr lang="de-DE" sz="3600" dirty="0"/>
-                        <a:t>69,43%</a:t>
+                        <a:rPr lang="de-DE" sz="3600" dirty="0">
+                          <a:latin typeface="Liberation Sans Narrow" panose="020B0606020202030204" pitchFamily="34" charset="0"/>
+                        </a:rPr>
+                        <a:t>69,43% / 64,13%</a:t>
                       </a:r>
-                      <a:endParaRPr sz="3600" dirty="0"/>
+                      <a:endParaRPr sz="3600" dirty="0">
+                        <a:latin typeface="Liberation Sans Narrow" panose="020B0606020202030204" pitchFamily="34" charset="0"/>
+                      </a:endParaRPr>
                     </a:p>
                   </a:txBody>
-                  <a:tcPr anchor="ctr">
+                  <a:tcPr marL="90000" anchor="ctr">
                     <a:lnL w="12700" cap="flat" cmpd="sng" algn="ctr">
                       <a:solidFill>
                         <a:schemeClr val="tx1"/>
@@ -3101,21 +3382,17 @@
                         <a:defRPr/>
                       </a:pPr>
                       <a:r>
-                        <a:rPr lang="de-DE" sz="3600" dirty="0"/>
-                        <a:t>N/A (not </a:t>
+                        <a:rPr lang="de-DE" sz="3600" dirty="0">
+                          <a:latin typeface="Liberation Sans Narrow" panose="020B0606020202030204" pitchFamily="34" charset="0"/>
+                        </a:rPr>
+                        <a:t>N/A</a:t>
                       </a:r>
-                      <a:r>
-                        <a:rPr lang="de-DE" sz="3600" dirty="0" err="1"/>
-                        <a:t>used</a:t>
-                      </a:r>
-                      <a:r>
-                        <a:rPr lang="de-DE" sz="3600" dirty="0"/>
-                        <a:t>)</a:t>
-                      </a:r>
-                      <a:endParaRPr sz="3600" dirty="0"/>
+                      <a:endParaRPr sz="3600" dirty="0">
+                        <a:latin typeface="Liberation Sans Narrow" panose="020B0606020202030204" pitchFamily="34" charset="0"/>
+                      </a:endParaRPr>
                     </a:p>
                   </a:txBody>
-                  <a:tcPr anchor="ctr">
+                  <a:tcPr marL="90000" anchor="ctr">
                     <a:lnL w="12700" cap="flat" cmpd="sng" algn="ctr">
                       <a:solidFill>
                         <a:schemeClr val="tx1"/>
@@ -3168,8 +3445,8 @@
         </p:nvSpPr>
         <p:spPr bwMode="auto">
           <a:xfrm>
-            <a:off x="1671316" y="33232399"/>
-            <a:ext cx="12029005" cy="913311"/>
+            <a:off x="1671316" y="33461912"/>
+            <a:ext cx="16345816" cy="921866"/>
           </a:xfrm>
           <a:prstGeom prst="rect">
             <a:avLst/>
@@ -3183,7 +3460,7 @@
           <a:effectLst/>
         </p:spPr>
         <p:txBody>
-          <a:bodyPr lIns="89992" tIns="44995" rIns="89992" bIns="44995">
+          <a:bodyPr wrap="square" lIns="89992" tIns="44995" rIns="89992" bIns="44995">
             <a:spAutoFit/>
           </a:bodyPr>
           <a:lstStyle/>
@@ -3195,7 +3472,7 @@
               <a:rPr lang="en-US" sz="5400" b="1" strike="noStrike" cap="small" noProof="0" dirty="0">
                 <a:latin typeface="Liberation Serif"/>
               </a:rPr>
-              <a:t>Sender and Receiver in Interaction</a:t>
+              <a:t>Sender and Receiver in Emergent Interaction</a:t>
             </a:r>
             <a:endParaRPr lang="en-US" sz="5400" noProof="0" dirty="0"/>
           </a:p>
@@ -3209,8 +3486,8 @@
         </p:nvSpPr>
         <p:spPr bwMode="auto">
           <a:xfrm>
-            <a:off x="1671316" y="25358407"/>
-            <a:ext cx="12017124" cy="913311"/>
+            <a:off x="1671316" y="25664613"/>
+            <a:ext cx="13177464" cy="921866"/>
           </a:xfrm>
           <a:prstGeom prst="rect">
             <a:avLst/>
@@ -3224,7 +3501,7 @@
           <a:effectLst/>
         </p:spPr>
         <p:txBody>
-          <a:bodyPr lIns="89992" tIns="44995" rIns="89992" bIns="44995">
+          <a:bodyPr wrap="square" lIns="89992" tIns="44995" rIns="89992" bIns="44995">
             <a:spAutoFit/>
           </a:bodyPr>
           <a:lstStyle/>
@@ -3236,7 +3513,7 @@
               <a:rPr lang="en-US" sz="5400" b="1" strike="noStrike" cap="small" noProof="0" dirty="0">
                 <a:latin typeface="Liberation Serif"/>
               </a:rPr>
-              <a:t>Sender in Supervised Generation</a:t>
+              <a:t>Sender in Supervised Generation (GRE)</a:t>
             </a:r>
             <a:endParaRPr lang="en-US" sz="5400" noProof="0" dirty="0"/>
           </a:p>
@@ -3402,6 +3679,49 @@
           </a:prstGeom>
         </p:spPr>
       </p:pic>
+      <p:sp>
+        <p:nvSpPr>
+          <p:cNvPr id="3" name="TextBox 2">
+            <a:extLst>
+              <a:ext uri="{FF2B5EF4-FFF2-40B4-BE49-F238E27FC236}">
+                <a16:creationId xmlns:a16="http://schemas.microsoft.com/office/drawing/2014/main" id="{ECB82B72-54F0-54AD-7EEC-8C92576EF4DE}"/>
+              </a:ext>
+            </a:extLst>
+          </p:cNvPr>
+          <p:cNvSpPr txBox="1"/>
+          <p:nvPr/>
+        </p:nvSpPr>
+        <p:spPr>
+          <a:xfrm>
+            <a:off x="12985435" y="41206799"/>
+            <a:ext cx="8022150" cy="954107"/>
+          </a:xfrm>
+          <a:prstGeom prst="rect">
+            <a:avLst/>
+          </a:prstGeom>
+          <a:noFill/>
+        </p:spPr>
+        <p:txBody>
+          <a:bodyPr wrap="square" rtlCol="0">
+            <a:spAutoFit/>
+          </a:bodyPr>
+          <a:lstStyle/>
+          <a:p>
+            <a:r>
+              <a:rPr lang="en-SE" sz="2800" dirty="0">
+                <a:latin typeface="Liberation Sans Narrow" panose="020B0606020202030204" pitchFamily="34" charset="0"/>
+              </a:rPr>
+              <a:t>Supported by the Swedish Research Council Project Grant (VR 2023-01552) </a:t>
+            </a:r>
+            <a:r>
+              <a:rPr lang="en-SE" sz="2800" b="1" dirty="0">
+                <a:latin typeface="Liberation Sans Narrow" panose="020B0606020202030204" pitchFamily="34" charset="0"/>
+              </a:rPr>
+              <a:t>Beyond Pixels and Words</a:t>
+            </a:r>
+          </a:p>
+        </p:txBody>
+      </p:sp>
     </p:spTree>
   </p:cSld>
   <p:clrMapOvr>

</xml_diff>